<commit_message>
Replace 24/7 with Dedicated
</commit_message>
<xml_diff>
--- a/public/presentations/presentation_en.pptx
+++ b/public/presentations/presentation_en.pptx
@@ -4165,7 +4165,7 @@
                 <a:ea typeface="Georgia" pitchFamily="34" charset="-122"/>
                 <a:cs typeface="Georgia" pitchFamily="34" charset="-120"/>
               </a:rPr>
-              <a:t>24/7</a:t>
+              <a:t>100%</a:t>
             </a:r>
             <a:endParaRPr lang="en-US" sz="2800" dirty="0"/>
           </a:p>
@@ -4204,7 +4204,7 @@
                 <a:ea typeface="Calibri" pitchFamily="34" charset="-122"/>
                 <a:cs typeface="Calibri" pitchFamily="34" charset="-120"/>
               </a:rPr>
-              <a:t>Support</a:t>
+              <a:t>Dedicated</a:t>
             </a:r>
             <a:endParaRPr lang="en-US" sz="1100" dirty="0"/>
           </a:p>

</xml_diff>